<commit_message>
Paper Tags deck: match one-pager (young musician, club shooting)
Co-Authored-By: Claude Opus 5.5 <noreply@anthropic.com>
Claude-Session: https://claude.ai/code/session_019Mre8MowFPXXHqKN7k1c4f
</commit_message>
<xml_diff>
--- a/pitch-decks/paper-tags-pitch-deck.pptx
+++ b/pitch-decks/paper-tags-pitch-deck.pptx
@@ -886,7 +886,7 @@
           </a:p>
           <a:p xmlns:a="http://schemas.openxmlformats.org/drawingml/2006/main">
             <a:r>
-              <a:t>The one-pager describes a later four-pass script at approximately 88 pages and a separate 85-page spec cut. The reviewed v3 is 86 screenplay pages. This deck avoids claiming a later draft has been verified. It uses the steakhouse valet opening and Agent Keller without a first name to reconcile source differences. Confidential development material.</a:t>
+              <a:t>The one-pager describes a later four-pass script at approximately 88 pages and a separate 85-page spec cut. The reviewed v3 is 86 screenplay pages. This deck avoids claiming a later draft has been verified. It uses the club shooting opening and Agent Keller without a first name to reconcile source differences. Confidential development material.</a:t>
             </a:r>
           </a:p>
         </p:txBody>
@@ -7434,7 +7434,7 @@
                   <a:srgbClr val="E9E8E3"/>
                 </a:solidFill>
               </a:rPr>
-              <a:t>A Black Atlanta detective investigating a young valet’s murder turns to the ex-lover she once imprisoned. When the stolen-car ring leads to her mentor and her teenage nephew, she must expose her own mistakes to save her family.</a:t>
+              <a:t>A Black Atlanta detective investigating a young musician’s murder turns to the ex-lover she once imprisoned. When the stolen-car ring leads to her mentor and her teenage nephew, she must expose her own mistakes to save her family.</a:t>
             </a:r>
           </a:p>
         </p:txBody>

</xml_diff>

<commit_message>
Paper Tags deck: match one-pager (young musician, club shooting) (#23)
Claude-Session: https://claude.ai/code/session_019Mre8MowFPXXHqKN7k1c4f

Co-authored-by: Claude Opus 5.5 <noreply@anthropic.com>
</commit_message>
<xml_diff>
--- a/pitch-decks/paper-tags-pitch-deck.pptx
+++ b/pitch-decks/paper-tags-pitch-deck.pptx
@@ -886,7 +886,7 @@
           </a:p>
           <a:p xmlns:a="http://schemas.openxmlformats.org/drawingml/2006/main">
             <a:r>
-              <a:t>The one-pager describes a later four-pass script at approximately 88 pages and a separate 85-page spec cut. The reviewed v3 is 86 screenplay pages. This deck avoids claiming a later draft has been verified. It uses the steakhouse valet opening and Agent Keller without a first name to reconcile source differences. Confidential development material.</a:t>
+              <a:t>The one-pager describes a later four-pass script at approximately 88 pages and a separate 85-page spec cut. The reviewed v3 is 86 screenplay pages. This deck avoids claiming a later draft has been verified. It uses the club shooting opening and Agent Keller without a first name to reconcile source differences. Confidential development material.</a:t>
             </a:r>
           </a:p>
         </p:txBody>
@@ -7434,7 +7434,7 @@
                   <a:srgbClr val="E9E8E3"/>
                 </a:solidFill>
               </a:rPr>
-              <a:t>A Black Atlanta detective investigating a young valet’s murder turns to the ex-lover she once imprisoned. When the stolen-car ring leads to her mentor and her teenage nephew, she must expose her own mistakes to save her family.</a:t>
+              <a:t>A Black Atlanta detective investigating a young musician’s murder turns to the ex-lover she once imprisoned. When the stolen-car ring leads to her mentor and her teenage nephew, she must expose her own mistakes to save her family.</a:t>
             </a:r>
           </a:p>
         </p:txBody>

</xml_diff>